<commit_message>
adjusting structure and content
</commit_message>
<xml_diff>
--- a/ai-beginner-bootcamp-outline/day_1/Day_1_Slides.pptx
+++ b/ai-beginner-bootcamp-outline/day_1/Day_1_Slides.pptx
@@ -510,7 +510,7 @@
           <a:lstStyle/>
           <a:p>
             <a:r>
-              <a:t>Welcome everyone warmly. Say: 'Take a breath — you are in the right room, and you do not need a technical background to be here.' Introduce yourself in 60 seconds, then ask 3-4 participants to shout out their job title (accountant, teacher, HR officer, trader). Point out the variety and say: 'Every single one of those roles is about to get faster this week.' Set expectations: Day 1 is about mindset and setup — we get our hands dirty by the end of today. Emphasise that the bootcamp is universal — this is not a developer course, it is a knowledge worker course.</a:t>
+              <a:t>Open warmly. Say: 'Welcome — you're in the right room.' Set expectations fast: this is a build-along bootcamp, not a lecture series. Ask the room a quick question: 'How many tabs do you have open right now?' Let people laugh. Then land the promise: by Day 5, everyone leaves with a working system, not just notes about one. Emphasise that Day 1 is deliberately gentle — today is about understanding and setup, not heavy lifting. Reassure the non-technical folks explicitly: 'If you have ever sent a WhatsApp message, you have the skills we need today.'</a:t>
             </a:r>
           </a:p>
         </p:txBody>
@@ -580,7 +580,7 @@
           <a:lstStyle/>
           <a:p>
             <a:r>
-              <a:t>This is the mindset slide — spend time here. Use a relatable story: 'Imagine you get a brilliant intern on Monday. Fast, tireless, has read the entire internet — but has never met your company, your clients, or your boss. Would you fire the intern because their first draft was wrong? No. You would coach them.' That is exactly the relationship you are building this week. Warn them about the two failure modes: people who refuse to use it, and people who blindly trust it. We are aiming for the middle — the skilled director. Ask the room: 'What is one task you do every week that you secretly hate?' Collect 3 answers on a flipchart — you will reference these all week.</a:t>
+              <a:t>Make this personal and relatable. Ask: 'Who here has saved an article, a voice note, or a PDF you swore you'd come back to?' Almost every hand goes up. Explain the digital graveyard — Google Drive folders, WhatsApp 'saved messages', screenshots nobody opens again. Key reframe to deliver slowly: 'The issue isn't that you forget. It's that you have no system for remembering on demand.' Human memory is for having ideas, not storing them. That's the gap a Second Brain fills.</a:t>
             </a:r>
           </a:p>
         </p:txBody>
@@ -650,7 +650,7 @@
           <a:lstStyle/>
           <a:p>
             <a:r>
-              <a:t>Keep this simple and non-technical. Use the phone keyboard analogy: 'When you type Good morning and your phone suggests sir — that is baby prediction. ChatGPT is that same idea, scaled up a billion times, with reasoning that emerges from the scale.' Stress the key insight: because it predicts rather than retrieves, it can confidently produce something that sounds perfect but is wrong. That is called a hallucination — we will cover it properly on the next slide. Do NOT go into transformers, tokens, or neural networks. If someone asks a deep technical question, park it: 'Great question — write it on the parking board, we will handle it in the Day 4 deep dive.'</a:t>
+              <a:t>Define the term plainly before adding AI. A Second Brain is simply an outside-your-head memory you actually trust. Note the evolution: people have done this for centuries with journals and commonplace books. What changed in the last two years is that the notebook can now talk back. Use the analogy that anchors the whole day: 'Old Second Brain = a filing cabinet. New Second Brain = a colleague who has read every file in that cabinet.' Stress that we're not replacing thinking — we're removing the friction before thinking.</a:t>
             </a:r>
           </a:p>
         </p:txBody>
@@ -720,7 +720,7 @@
           <a:lstStyle/>
           <a:p>
             <a:r>
-              <a:t>Frame this as a hiring decision, not a religious war. Tell them: 'You are not marrying one — most professionals keep two open.' Give practical Nigerian context: mention that payment for subscriptions can be done with a virtual dollar card, and that free tiers are genuinely enough to complete this bootcamp. Recommend everyone create accounts on at least two so they can compare outputs. Mention mobile apps and voice mode — many participants will get their biggest wins on their phone during traffic or between meetings. Reassure: 'We will use ChatGPT as our common classroom tool so nobody gets lost, but everything you learn transfers.'</a:t>
+              <a:t>This is the mental model for the entire bootcamp — spend real time here. Most people treat AI like a search engine and get generic answers. Instead, treat it like a sharp intern who started this morning: capable, eager, and completely clueless about your context. Walk through the three things: the job description (we'll call this a system prompt), the training materials (your documents and notes), and feedback (iterating on the output). Say clearly: 'If your assistant gives you rubbish, ask yourself what a new hire would have needed to know that you didn't tell them.' This one shift separates people who love AI from people who gave up on it.</a:t>
             </a:r>
           </a:p>
         </p:txBody>
@@ -790,7 +790,7 @@
           <a:lstStyle/>
           <a:p>
             <a:r>
-              <a:t>This is a live, do-it-with-me segment — slow down and walk the room. Do not advance until at least 80% of hands are up. Custom Instructions is the highest-leverage 5 minutes of the whole day: have them write two things — (1) 'Who are you?' e.g. 'I am an HR manager at a 40-person logistics firm in Lagos', and (2) 'How should the AI respond?' e.g. 'Be concise, use British English, avoid corporate jargon, always ask me a clarifying question before writing long documents.' Explain that this instruction now applies to EVERY future chat — they just trained their intern once instead of every morning. Have volunteers read their custom instructions aloud.</a:t>
+              <a:t>Introduce this as the workflow that structures the rest of the week. Use one running example the class can follow — say, a 40-page industry report. Capture: drop it in. Organise: tag it by project. Distil: 'give me the five decisions this report should influence.' Create: 'draft a one-page brief for my team based on it.' Point out that most people only ever do step one — they capture and stop, which is why they end up with a graveyard. Preview the week lightly: Day 2 focuses on capture and organisation, Day 3 on giving the brain your knowledge, Day 4 on automation, Day 5 on shipping your own build.</a:t>
             </a:r>
           </a:p>
         </p:txBody>
@@ -860,7 +860,7 @@
           <a:lstStyle/>
           <a:p>
             <a:r>
-              <a:t>Contrast two prompts on screen. Bad: 'Write an email about the delay.' Good: 'You are a client relations manager at a Lagos-based logistics company. Our client's shipment is 3 days late due to port congestion. Write a 150-word email to the client that apologises, explains without making excuses, gives a new delivery date of Friday, and offers a 5% discount. Professional but warm tone.' Run both live so the room SEES the difference — this moment usually gets an audible reaction. Then hammer the T: 'The first output is never the final output. Reply with make it shorter and less apologetic.' That back-and-forth is the actual skill. Give them 10 minutes to write a CRAFT prompt for the task they said they hate, from Slide 2.</a:t>
+              <a:t>Head off tool anxiety immediately. Say: 'You do not need every subscription on the internet.' Recommend one AI assistant, one notes app, and later one automation layer. If people already use Notion or Obsidian, they keep it — we're building on top of what exists. Mention that free tiers are enough to finish the bootcamp, and note where paid tiers help (longer documents, file uploads) without pressuring anyone. Warn about the most common trap: tool-hopping. Someone will want to redesign their whole system today — tell them to resist it. We are building one small working brain, then growing it.</a:t>
             </a:r>
           </a:p>
         </p:txBody>
@@ -930,7 +930,7 @@
           <a:lstStyle/>
           <a:p>
             <a:r>
-              <a:t>Be serious but not scary here. Share a real cautionary example (the lawyers who submitted AI-invented case citations to court). Explain that hallucination is not a bug they can turn off — it is a side effect of how prediction works, so verification is a permanent part of the workflow, not a beginner phase. On data safety: give them a simple test — 'If you would not post it in a public WhatsApp group, do not paste it in a free AI chat.' Teach the anonymisation habit: replace real names with Client A, real figures with rounded placeholders. Mention that enterprise/team plans have stronger data protections if their company is ready for that conversation.</a:t>
+              <a:t>Move into hands-on mode — this is the doing part of Day 1. Walk them through live. For the job description, give a template on screen: 'You are my research assistant. I work in [field]. When I share material, summarise in plain English, use short paragraphs, and always end with three questions I should be asking. Never invent facts — if you don't know, say so.' Give people 10 minutes to write their own. Then have them upload or paste one real document — a report, lecture note, contract, or meeting transcript. The three-question test is the magic moment: when the AI answers using THEIR material, the concept lands emotionally. Circulate and help anyone stuck. Ask two or three volunteers to read out what their assistant said.</a:t>
             </a:r>
           </a:p>
         </p:txBody>
@@ -1000,7 +1000,7 @@
           <a:lstStyle/>
           <a:p>
             <a:r>
-              <a:t>Close with energy. Do a quick round-the-room: each person says in one sentence the task they will delegate tonight — public commitment drives completion. Emphasise the 'bring your failure' instruction: say 'The failures are more valuable than the wins, because that is where the real learning lives — I want to see broken outputs tomorrow morning.' Share the WhatsApp/community group link for overnight questions and remind them the slides and prompt templates will be sent out this evening. Finish with the line: 'You did not learn about AI today. You hired it. Tomorrow we train it.'</a:t>
+              <a:t>Close with energy and a clear next action. Keep the homework light but non-negotiable — 10 items only, and they can be messy. The point is to build the capture reflex, not a perfect archive. Remind them to iterate on the job description; the second version is always better than the first. Tease Day 2: tomorrow we stop copying and pasting and start building a proper inbox for our brain. Final line to leave them with: 'You didn't just open a chatbot today — you hired someone. Tomorrow, we train them.' Share the community or WhatsApp group link and invite people to post their first assistant output tonight.</a:t>
             </a:r>
           </a:p>
         </p:txBody>
@@ -4121,7 +4121,7 @@
               </a:defRPr>
             </a:pPr>
             <a:r>
-              <a:t>Welcome to Day 1: Hire the Brain</a:t>
+              <a:t>Welcome to the Second Brain Bootcamp</a:t>
             </a:r>
           </a:p>
         </p:txBody>
@@ -4151,7 +4151,7 @@
               </a:defRPr>
             </a:pPr>
             <a:r>
-              <a:t>5 days, one goal: you leave with an AI teammate that actually works for you</a:t>
+              <a:t>5 days to build an AI-powered thinking partner that never forgets</a:t>
             </a:r>
           </a:p>
           <a:p>
@@ -4164,7 +4164,7 @@
               </a:defRPr>
             </a:pPr>
             <a:r>
-              <a:t>No coding required — if you can send a WhatsApp message, you can do this</a:t>
+              <a:t>Day 1: Hire the Brain — meet your new assistant and set it up</a:t>
             </a:r>
           </a:p>
           <a:p>
@@ -4177,7 +4177,7 @@
               </a:defRPr>
             </a:pPr>
             <a:r>
-              <a:t>Today: what AI really is, why it matters for YOUR job, and getting your tools set up</a:t>
+              <a:t>No coding experience required — if you can chat, you can build</a:t>
             </a:r>
           </a:p>
           <a:p>
@@ -4190,7 +4190,7 @@
               </a:defRPr>
             </a:pPr>
             <a:r>
-              <a:t>By 5pm today you will have your first working AI assistant</a:t>
+              <a:t>By Friday: a working Second Brain that reads, remembers, and reasons with you</a:t>
             </a:r>
           </a:p>
         </p:txBody>
@@ -4245,7 +4245,7 @@
               </a:defRPr>
             </a:pPr>
             <a:r>
-              <a:t>The Big Shift: From Doing to Directing</a:t>
+              <a:t>The Problem: Your Brain Was Never Built for This</a:t>
             </a:r>
           </a:p>
         </p:txBody>
@@ -4275,7 +4275,7 @@
               </a:defRPr>
             </a:pPr>
             <a:r>
-              <a:t>Knowledge work = reading, writing, summarising, analysing, deciding</a:t>
+              <a:t>We consume more information in a day than our grandparents did in a month</a:t>
             </a:r>
           </a:p>
           <a:p>
@@ -4288,7 +4288,7 @@
               </a:defRPr>
             </a:pPr>
             <a:r>
-              <a:t>AI can now do the first 80% of most of those tasks in seconds</a:t>
+              <a:t>Notes get written once and never read again — the 'digital graveyard'</a:t>
             </a:r>
           </a:p>
           <a:p>
@@ -4301,7 +4301,7 @@
               </a:defRPr>
             </a:pPr>
             <a:r>
-              <a:t>Your new job is not typing — it is instructing, reviewing and approving</a:t>
+              <a:t>You don't have a knowledge problem, you have a retrieval problem</a:t>
             </a:r>
           </a:p>
           <a:p>
@@ -4314,7 +4314,7 @@
               </a:defRPr>
             </a:pPr>
             <a:r>
-              <a:t>The people who win are not the smartest — they are the best delegators</a:t>
+              <a:t>Great ideas die not from lack of thinking, but from lack of remembering</a:t>
             </a:r>
           </a:p>
         </p:txBody>
@@ -4369,7 +4369,7 @@
               </a:defRPr>
             </a:pPr>
             <a:r>
-              <a:t>So What Actually Is This Thing?</a:t>
+              <a:t>What Is a 'Second Brain'?</a:t>
             </a:r>
           </a:p>
         </p:txBody>
@@ -4399,7 +4399,7 @@
               </a:defRPr>
             </a:pPr>
             <a:r>
-              <a:t>An LLM (Large Language Model) is a very advanced prediction engine for words</a:t>
+              <a:t>A trusted external system that stores what you learn — so you can think, not memorise</a:t>
             </a:r>
           </a:p>
           <a:p>
@@ -4412,7 +4412,7 @@
               </a:defRPr>
             </a:pPr>
             <a:r>
-              <a:t>It read a huge portion of the internet and learned patterns in language</a:t>
+              <a:t>Traditional version: notebooks, Notion, Evernote (you still do the searching)</a:t>
             </a:r>
           </a:p>
           <a:p>
@@ -4425,7 +4425,7 @@
               </a:defRPr>
             </a:pPr>
             <a:r>
-              <a:t>It does not 'look up' answers — it generates the most likely next words</a:t>
+              <a:t>AI version: a brain you can TALK to — it finds, summarises, and connects for you</a:t>
             </a:r>
           </a:p>
           <a:p>
@@ -4438,7 +4438,7 @@
               </a:defRPr>
             </a:pPr>
             <a:r>
-              <a:t>That is why it is amazing at drafting, and unreliable at exact facts</a:t>
+              <a:t>Think of it as hiring the world's most patient research assistant</a:t>
             </a:r>
           </a:p>
         </p:txBody>
@@ -4493,7 +4493,7 @@
               </a:defRPr>
             </a:pPr>
             <a:r>
-              <a:t>Meet Your Candidates: Choosing Your Brain</a:t>
+              <a:t>Why 'Hire' the Brain? The Employee Mindset</a:t>
             </a:r>
           </a:p>
         </p:txBody>
@@ -4523,7 +4523,7 @@
               </a:defRPr>
             </a:pPr>
             <a:r>
-              <a:t>ChatGPT (OpenAI) — the all-rounder, best ecosystem and custom GPTs</a:t>
+              <a:t>Treat your AI like a new hire — brilliant, fast, but knows nothing about YOU on Day 1</a:t>
             </a:r>
           </a:p>
           <a:p>
@@ -4536,7 +4536,7 @@
               </a:defRPr>
             </a:pPr>
             <a:r>
-              <a:t>Claude (Anthropic) — best for long documents, careful writing and analysis</a:t>
+              <a:t>Every employee needs three things: a job description, training materials, and feedback</a:t>
             </a:r>
           </a:p>
           <a:p>
@@ -4549,7 +4549,7 @@
               </a:defRPr>
             </a:pPr>
             <a:r>
-              <a:t>Gemini (Google) — strongest if you live inside Gmail, Docs and Sheets</a:t>
+              <a:t>Bad results are usually a briefing problem, not an intelligence problem</a:t>
             </a:r>
           </a:p>
           <a:p>
@@ -4562,7 +4562,7 @@
               </a:defRPr>
             </a:pPr>
             <a:r>
-              <a:t>Free tiers are good; paid tiers (~$20/mo) are where the real power is</a:t>
+              <a:t>This week you become the manager, not the machine operator</a:t>
             </a:r>
           </a:p>
         </p:txBody>
@@ -4617,7 +4617,7 @@
               </a:defRPr>
             </a:pPr>
             <a:r>
-              <a:t>Hands-On: Setting Up Your Workspace</a:t>
+              <a:t>The 4 Jobs Your Second Brain Will Do</a:t>
             </a:r>
           </a:p>
         </p:txBody>
@@ -4647,7 +4647,7 @@
               </a:defRPr>
             </a:pPr>
             <a:r>
-              <a:t>Step 1: Create your account with a work-appropriate email (not your fun email)</a:t>
+              <a:t>CAPTURE — pull in notes, articles, PDFs, voice notes and meeting transcripts</a:t>
             </a:r>
           </a:p>
           <a:p>
@@ -4660,7 +4660,7 @@
               </a:defRPr>
             </a:pPr>
             <a:r>
-              <a:t>Step 2: Turn on chat history and explore the sidebar — projects and folders</a:t>
+              <a:t>ORGANISE — structure information so it can be found again in seconds</a:t>
             </a:r>
           </a:p>
           <a:p>
@@ -4673,7 +4673,7 @@
               </a:defRPr>
             </a:pPr>
             <a:r>
-              <a:t>Step 3: Fill in Custom Instructions — tell it who you are and how you write</a:t>
+              <a:t>DISTIL — summarise long material down to what actually matters</a:t>
             </a:r>
           </a:p>
           <a:p>
@@ -4686,7 +4686,7 @@
               </a:defRPr>
             </a:pPr>
             <a:r>
-              <a:t>Step 4: Bookmark it on desktop AND install the mobile app</a:t>
+              <a:t>CREATE — turn what you know into drafts, plans, posts and decisions</a:t>
             </a:r>
           </a:p>
         </p:txBody>
@@ -4741,7 +4741,7 @@
               </a:defRPr>
             </a:pPr>
             <a:r>
-              <a:t>Your First Real Prompt: The C.R.A.F.T. Formula</a:t>
+              <a:t>Meet Your Toolkit (Keep It Boring, Keep It Working)</a:t>
             </a:r>
           </a:p>
         </p:txBody>
@@ -4771,7 +4771,7 @@
               </a:defRPr>
             </a:pPr>
             <a:r>
-              <a:t>C — Context: who you are and what the situation is</a:t>
+              <a:t>The Brain: ChatGPT, Claude or Gemini — pick one, stick with it this week</a:t>
             </a:r>
           </a:p>
           <a:p>
@@ -4784,7 +4784,7 @@
               </a:defRPr>
             </a:pPr>
             <a:r>
-              <a:t>R — Role: 'Act as a senior communications officer...'</a:t>
+              <a:t>The Memory: a notes home (Notion, Obsidian or Google Docs — your choice)</a:t>
             </a:r>
           </a:p>
           <a:p>
@@ -4797,7 +4797,7 @@
               </a:defRPr>
             </a:pPr>
             <a:r>
-              <a:t>A — Action: the exact task, one clear verb</a:t>
+              <a:t>The Connector: an automation tool to move things between them (we'll meet this on Day 4)</a:t>
             </a:r>
           </a:p>
           <a:p>
@@ -4810,20 +4810,7 @@
               </a:defRPr>
             </a:pPr>
             <a:r>
-              <a:t>F — Format: bullets, table, email, 200 words, tone</a:t>
-            </a:r>
-          </a:p>
-          <a:p>
-            <a:pPr>
-              <a:defRPr sz="2400">
-                <a:solidFill>
-                  <a:srgbClr val="FFFFFF"/>
-                </a:solidFill>
-                <a:latin typeface="Arial"/>
-              </a:defRPr>
-            </a:pPr>
-            <a:r>
-              <a:t>T — Tighten: react to the draft and ask for one improvement</a:t>
+              <a:t>Rule of the week: simple tools you use beat perfect tools you don't</a:t>
             </a:r>
           </a:p>
         </p:txBody>
@@ -4878,7 +4865,7 @@
               </a:defRPr>
             </a:pPr>
             <a:r>
-              <a:t>The Rules: Trust, Verify and Stay Safe</a:t>
+              <a:t>Today's Build: Your First Hire</a:t>
             </a:r>
           </a:p>
         </p:txBody>
@@ -4908,7 +4895,7 @@
               </a:defRPr>
             </a:pPr>
             <a:r>
-              <a:t>Hallucination is real — AI can invent statistics, laws, citations and names</a:t>
+              <a:t>Step 1: Create your account and open a fresh, dedicated chat workspace</a:t>
             </a:r>
           </a:p>
           <a:p>
@@ -4921,7 +4908,7 @@
               </a:defRPr>
             </a:pPr>
             <a:r>
-              <a:t>Never paste client data, staff records, passwords or unreleased financials</a:t>
+              <a:t>Step 2: Write your assistant's job description — role, tone, and what it should never do</a:t>
             </a:r>
           </a:p>
           <a:p>
@@ -4934,7 +4921,7 @@
               </a:defRPr>
             </a:pPr>
             <a:r>
-              <a:t>You own the output — your name goes on it, so you check it</a:t>
+              <a:t>Step 3: Feed it one real document from your work or studies</a:t>
             </a:r>
           </a:p>
           <a:p>
@@ -4947,7 +4934,7 @@
               </a:defRPr>
             </a:pPr>
             <a:r>
-              <a:t>Rule of thumb: use AI for the draft, use your brain for the decision</a:t>
+              <a:t>Step 4: Ask three questions only someone who read that document could answer</a:t>
             </a:r>
           </a:p>
         </p:txBody>
@@ -5002,7 +4989,7 @@
               </a:defRPr>
             </a:pPr>
             <a:r>
-              <a:t>Wrap-Up and Tonight's Mission</a:t>
+              <a:t>Homework &amp; What's Coming Tomorrow</a:t>
             </a:r>
           </a:p>
         </p:txBody>
@@ -5032,7 +5019,7 @@
               </a:defRPr>
             </a:pPr>
             <a:r>
-              <a:t>Today you hired the brain, gave it your context, and wrote your first real prompt</a:t>
+              <a:t>Homework: capture 10 pieces of information you'd normally lose (links, notes, voice memos)</a:t>
             </a:r>
           </a:p>
           <a:p>
@@ -5045,7 +5032,7 @@
               </a:defRPr>
             </a:pPr>
             <a:r>
-              <a:t>Homework: use AI on 3 real work tasks before tomorrow — save the best and the worst</a:t>
+              <a:t>Refine your assistant's job description at least once based on today's answers</a:t>
             </a:r>
           </a:p>
           <a:p>
@@ -5058,7 +5045,7 @@
               </a:defRPr>
             </a:pPr>
             <a:r>
-              <a:t>Bring one output that failed — we will fix it together live</a:t>
+              <a:t>Tomorrow — Day 2: 'Feed the Brain' — building a capture system that runs on autopilot</a:t>
             </a:r>
           </a:p>
           <a:p>
@@ -5071,7 +5058,7 @@
               </a:defRPr>
             </a:pPr>
             <a:r>
-              <a:t>Tomorrow, Day 2: Train the Brain — prompt patterns that get expert-level results</a:t>
+              <a:t>Come with one real problem you want your Second Brain to solve this week</a:t>
             </a:r>
           </a:p>
         </p:txBody>

</xml_diff>